<commit_message>
Migrar para vertical-data.pages.dev e levar o deck para a marca
Cloudflare Pages não renomeia projeto — a URL sai do nome, então foi criado
`vertical-data` e publicado nele. O antigo `painel-cerurb` segue no ar, com
senha; aposentá-lo é decisão à parte, porque o link já foi compartilhado.

Projeto novo não herda variável: o middleware responde 503 até que
PAINEL_USUARIO/PAINEL_SENHA existam no projeto. Falha na direção certa, e o
script agora diz o que fazer.

Deck:
- dash_hero.png e dash_scatter.png recapturados na marca, mesmas dimensões
  (1440x1330 e 1440x620), pelo Chrome headless em 1x e 3x
- paleta de identidade remapeada (verde quente -> navy/teal); o ocre ficou,
  porque é semântico nos slides e trocá-lo às cegas mexeria em contraste
- selo da capa: T -> VD
- Georgia continua: Inter não existe na máquina de quem abre o .pptx e cairia
  num fallback arbitrário. A fonte da marca vale onde ela é garantida — na web
</commit_message>
<xml_diff>
--- a/apresentacao/apresentacao-planejamento-painel-territorial.pptx
+++ b/apresentacao/apresentacao-planejamento-painel-territorial.pptx
@@ -2014,7 +2014,7 @@
     <p:bg>
       <p:bgPr>
         <a:solidFill>
-          <a:srgbClr val="0F332C"/>
+          <a:srgbClr val="071A2E"/>
         </a:solidFill>
       </p:bgPr>
     </p:bg>
@@ -2047,11 +2047,11 @@
             <a:avLst/>
           </a:prstGeom>
           <a:solidFill>
-            <a:srgbClr val="17453D"/>
+            <a:srgbClr val="0B2545"/>
           </a:solidFill>
           <a:ln w="19050">
             <a:solidFill>
-              <a:srgbClr val="8FD0C0"/>
+              <a:srgbClr val="2FD5C0"/>
             </a:solidFill>
             <a:prstDash val="solid"/>
           </a:ln>
@@ -2082,53 +2082,53 @@
               <a:buNone/>
             </a:pPr>
             <a:r>
-              <a:rPr lang="en-US" sz="2200" b="1" dirty="0">
-                <a:solidFill>
-                  <a:srgbClr val="8FD0C0"/>
+              <a:rPr lang="en-US" sz="1400" b="1" dirty="0">
+                <a:solidFill>
+                  <a:srgbClr val="2FD5C0"/>
+                </a:solidFill>
+                <a:latin typeface="Arial" pitchFamily="34" charset="0"/>
+                <a:ea typeface="Arial" pitchFamily="34" charset="-122"/>
+                <a:cs typeface="Arial" pitchFamily="34" charset="-120"/>
+              </a:rPr>
+              <a:t>VD</a:t>
+            </a:r>
+            <a:endParaRPr lang="en-US" sz="2200" dirty="0"/>
+          </a:p>
+        </p:txBody>
+      </p:sp>
+      <p:sp>
+        <p:nvSpPr>
+          <p:cNvPr id="4" name="Text 2"/>
+          <p:cNvSpPr/>
+          <p:nvPr/>
+        </p:nvSpPr>
+        <p:spPr>
+          <a:xfrm>
+            <a:off x="777240" y="1965960"/>
+            <a:ext cx="10607040" cy="1005840"/>
+          </a:xfrm>
+          <a:prstGeom prst="rect">
+            <a:avLst/>
+          </a:prstGeom>
+          <a:noFill/>
+          <a:ln/>
+        </p:spPr>
+        <p:txBody>
+          <a:bodyPr wrap="square" lIns="0" tIns="0" rIns="0" bIns="0" rtlCol="0" anchor="ctr"/>
+          <a:lstStyle/>
+          <a:p>
+            <a:pPr indent="0" marL="0">
+              <a:buNone/>
+            </a:pPr>
+            <a:r>
+              <a:rPr lang="en-US" sz="4800" b="1" dirty="0">
+                <a:solidFill>
+                  <a:srgbClr val="F4F6F8"/>
                 </a:solidFill>
                 <a:latin typeface="Georgia" pitchFamily="34" charset="0"/>
                 <a:ea typeface="Georgia" pitchFamily="34" charset="-122"/>
                 <a:cs typeface="Georgia" pitchFamily="34" charset="-120"/>
               </a:rPr>
-              <a:t>T</a:t>
-            </a:r>
-            <a:endParaRPr lang="en-US" sz="2200" dirty="0"/>
-          </a:p>
-        </p:txBody>
-      </p:sp>
-      <p:sp>
-        <p:nvSpPr>
-          <p:cNvPr id="4" name="Text 2"/>
-          <p:cNvSpPr/>
-          <p:nvPr/>
-        </p:nvSpPr>
-        <p:spPr>
-          <a:xfrm>
-            <a:off x="777240" y="1965960"/>
-            <a:ext cx="10607040" cy="1005840"/>
-          </a:xfrm>
-          <a:prstGeom prst="rect">
-            <a:avLst/>
-          </a:prstGeom>
-          <a:noFill/>
-          <a:ln/>
-        </p:spPr>
-        <p:txBody>
-          <a:bodyPr wrap="square" lIns="0" tIns="0" rIns="0" bIns="0" rtlCol="0" anchor="ctr"/>
-          <a:lstStyle/>
-          <a:p>
-            <a:pPr indent="0" marL="0">
-              <a:buNone/>
-            </a:pPr>
-            <a:r>
-              <a:rPr lang="en-US" sz="4800" b="1" dirty="0">
-                <a:solidFill>
-                  <a:srgbClr val="F7F5EE"/>
-                </a:solidFill>
-                <a:latin typeface="Georgia" pitchFamily="34" charset="0"/>
-                <a:ea typeface="Georgia" pitchFamily="34" charset="-122"/>
-                <a:cs typeface="Georgia" pitchFamily="34" charset="-120"/>
-              </a:rPr>
               <a:t>Painel de Gestão Territorial</a:t>
             </a:r>
             <a:endParaRPr lang="en-US" sz="4800" dirty="0"/>
@@ -2162,7 +2162,7 @@
             <a:r>
               <a:rPr lang="en-US" sz="2100" dirty="0">
                 <a:solidFill>
-                  <a:srgbClr val="F7F5EE"/>
+                  <a:srgbClr val="F4F6F8"/>
                 </a:solidFill>
               </a:rPr>
               <a:t>Do protótipo ao dado real </a:t>
@@ -2209,7 +2209,7 @@
             <a:r>
               <a:rPr lang="en-US" sz="1400" dirty="0">
                 <a:solidFill>
-                  <a:srgbClr val="9FBBB2"/>
+                  <a:srgbClr val="93AAC0"/>
                 </a:solidFill>
               </a:rPr>
               <a:t>Material de planejamento · não é proposta comercial nem produto final</a:t>
@@ -2268,7 +2268,7 @@
             <a:r>
               <a:rPr lang="en-US" sz="1300" dirty="0">
                 <a:solidFill>
-                  <a:srgbClr val="9FBBB2"/>
+                  <a:srgbClr val="93AAC0"/>
                 </a:solidFill>
               </a:rPr>
               <a:t>setembro de 2026 · Teresina, PI</a:t>
@@ -2336,7 +2336,7 @@
             <a:r>
               <a:rPr lang="en-US" sz="3000" b="1" dirty="0">
                 <a:solidFill>
-                  <a:srgbClr val="20261F"/>
+                  <a:srgbClr val="0B2545"/>
                 </a:solidFill>
                 <a:latin typeface="Georgia" pitchFamily="34" charset="0"/>
                 <a:ea typeface="Georgia" pitchFamily="34" charset="-122"/>
@@ -2375,7 +2375,7 @@
             <a:r>
               <a:rPr lang="en-US" sz="1400" dirty="0">
                 <a:solidFill>
-                  <a:srgbClr val="6E7266"/>
+                  <a:srgbClr val="5B6B7A"/>
                 </a:solidFill>
               </a:rPr>
               <a:t>Entrada + primeiro ano cabem numa dispensa de serviços — sem licitação.</a:t>
@@ -2405,7 +2405,7 @@
           </a:solidFill>
           <a:ln w="12700">
             <a:solidFill>
-              <a:srgbClr val="D9D4C4"/>
+              <a:srgbClr val="E2E6EA"/>
             </a:solidFill>
             <a:prstDash val="solid"/>
           </a:ln>
@@ -2445,7 +2445,7 @@
             <a:r>
               <a:rPr lang="en-US" sz="1300" b="1" spc="100" kern="0" dirty="0">
                 <a:solidFill>
-                  <a:srgbClr val="6E7266"/>
+                  <a:srgbClr val="5B6B7A"/>
                 </a:solidFill>
               </a:rPr>
               <a:t>Diagnóstico</a:t>
@@ -2481,7 +2481,7 @@
             <a:r>
               <a:rPr lang="en-US" sz="3200" b="1" dirty="0">
                 <a:solidFill>
-                  <a:srgbClr val="17453D"/>
+                  <a:srgbClr val="0B2545"/>
                 </a:solidFill>
                 <a:latin typeface="Georgia" pitchFamily="34" charset="0"/>
                 <a:ea typeface="Georgia" pitchFamily="34" charset="-122"/>
@@ -2523,7 +2523,7 @@
             <a:r>
               <a:rPr lang="en-US" sz="1250" dirty="0">
                 <a:solidFill>
-                  <a:srgbClr val="6E7266"/>
+                  <a:srgbClr val="5B6B7A"/>
                 </a:solidFill>
               </a:rPr>
               <a:t>decide numa reunião; mapeia o cadastro, o gap CIB e o valor venal estimado</a:t>
@@ -2553,7 +2553,7 @@
           </a:solidFill>
           <a:ln w="12700">
             <a:solidFill>
-              <a:srgbClr val="D9D4C4"/>
+              <a:srgbClr val="E2E6EA"/>
             </a:solidFill>
             <a:prstDash val="solid"/>
           </a:ln>
@@ -2593,7 +2593,7 @@
             <a:r>
               <a:rPr lang="en-US" sz="1300" b="1" spc="100" kern="0" dirty="0">
                 <a:solidFill>
-                  <a:srgbClr val="6E7266"/>
+                  <a:srgbClr val="5B6B7A"/>
                 </a:solidFill>
               </a:rPr>
               <a:t>Conformidade</a:t>
@@ -2671,7 +2671,7 @@
             <a:r>
               <a:rPr lang="en-US" sz="1250" dirty="0">
                 <a:solidFill>
-                  <a:srgbClr val="6E7266"/>
+                  <a:srgbClr val="5B6B7A"/>
                 </a:solidFill>
               </a:rPr>
               <a:t>saneamento + conector CADURB + remessa aceita em homologação</a:t>
@@ -2701,7 +2701,7 @@
           </a:solidFill>
           <a:ln w="12700">
             <a:solidFill>
-              <a:srgbClr val="D9D4C4"/>
+              <a:srgbClr val="E2E6EA"/>
             </a:solidFill>
             <a:prstDash val="solid"/>
           </a:ln>
@@ -2741,7 +2741,7 @@
             <a:r>
               <a:rPr lang="en-US" sz="1300" b="1" spc="100" kern="0" dirty="0">
                 <a:solidFill>
-                  <a:srgbClr val="6E7266"/>
+                  <a:srgbClr val="5B6B7A"/>
                 </a:solidFill>
               </a:rPr>
               <a:t>Manutenção</a:t>
@@ -2777,7 +2777,7 @@
             <a:r>
               <a:rPr lang="en-US" sz="3200" b="1" dirty="0">
                 <a:solidFill>
-                  <a:srgbClr val="B14B34"/>
+                  <a:srgbClr val="C03A24"/>
                 </a:solidFill>
                 <a:latin typeface="Georgia" pitchFamily="34" charset="0"/>
                 <a:ea typeface="Georgia" pitchFamily="34" charset="-122"/>
@@ -2819,7 +2819,7 @@
             <a:r>
               <a:rPr lang="en-US" sz="1250" dirty="0">
                 <a:solidFill>
-                  <a:srgbClr val="6E7266"/>
+                  <a:srgbClr val="5B6B7A"/>
                 </a:solidFill>
               </a:rPr>
               <a:t>atualização contínua, dashboard e relatórios de gestão</a:t>
@@ -2855,7 +2855,7 @@
             <a:r>
               <a:rPr lang="en-US" sz="3600" b="1" dirty="0">
                 <a:solidFill>
-                  <a:srgbClr val="17453D"/>
+                  <a:srgbClr val="0B2545"/>
                 </a:solidFill>
                 <a:latin typeface="Georgia" pitchFamily="34" charset="0"/>
                 <a:ea typeface="Georgia" pitchFamily="34" charset="-122"/>
@@ -2894,7 +2894,7 @@
             <a:r>
               <a:rPr lang="en-US" sz="1300" dirty="0">
                 <a:solidFill>
-                  <a:srgbClr val="6E7266"/>
+                  <a:srgbClr val="5B6B7A"/>
                 </a:solidFill>
               </a:rPr>
               <a:t>teto de dispensa para serviços em 2026 (art. 75, II, Lei 14.133) — folga de 2× sobre o ticket cheio.</a:t>
@@ -2933,7 +2933,7 @@
             <a:r>
               <a:rPr lang="en-US" sz="1250" dirty="0">
                 <a:solidFill>
-                  <a:srgbClr val="20261F"/>
+                  <a:srgbClr val="0B2545"/>
                 </a:solidFill>
               </a:rPr>
               <a:t>O produto inclui o dossiê de contratação: minuta de dispensa, estimativa de preço e caminho orçamentário (outras despesas correntes / serviços PJ). Subsídio de aquisição, quando usado, é em produto — nunca em desconto.</a:t>
@@ -2969,7 +2969,7 @@
             <a:r>
               <a:rPr lang="en-US" sz="1050" dirty="0">
                 <a:solidFill>
-                  <a:srgbClr val="6E7266"/>
+                  <a:srgbClr val="5B6B7A"/>
                 </a:solidFill>
               </a:rPr>
               <a:t>Decreto 12.807/2025 (limites 2026) · referências de mercado: contratos Geopixel ~R$ 270 mil (cadastro, 2019).</a:t>
@@ -3005,7 +3005,7 @@
             <a:r>
               <a:rPr lang="en-US" sz="1100" dirty="0">
                 <a:solidFill>
-                  <a:srgbClr val="6E7266"/>
+                  <a:srgbClr val="5B6B7A"/>
                 </a:solidFill>
               </a:rPr>
               <a:t>10</a:t>
@@ -3028,7 +3028,7 @@
     <p:bg>
       <p:bgPr>
         <a:solidFill>
-          <a:srgbClr val="0F332C"/>
+          <a:srgbClr val="071A2E"/>
         </a:solidFill>
       </p:bgPr>
     </p:bg>
@@ -3073,7 +3073,7 @@
             <a:r>
               <a:rPr lang="en-US" sz="3400" b="1" dirty="0">
                 <a:solidFill>
-                  <a:srgbClr val="F7F5EE"/>
+                  <a:srgbClr val="F4F6F8"/>
                 </a:solidFill>
                 <a:latin typeface="Georgia" pitchFamily="34" charset="0"/>
                 <a:ea typeface="Georgia" pitchFamily="34" charset="-122"/>
@@ -3112,7 +3112,7 @@
             <a:r>
               <a:rPr lang="en-US" sz="1450" dirty="0">
                 <a:solidFill>
-                  <a:srgbClr val="9FBBB2"/>
+                  <a:srgbClr val="93AAC0"/>
                 </a:solidFill>
               </a:rPr>
               <a:t>Janela prática de assinatura: novembro–dezembro. Tudo abaixo é trabalho de campo — a análise está feita e verificada.</a:t>
@@ -3190,7 +3190,7 @@
             <a:r>
               <a:rPr lang="en-US" sz="1450" b="1" dirty="0">
                 <a:solidFill>
-                  <a:srgbClr val="F7F5EE"/>
+                  <a:srgbClr val="F4F6F8"/>
                 </a:solidFill>
               </a:rPr>
               <a:t>Disparar os e-SIC  —  </a:t>
@@ -3204,7 +3204,7 @@
             <a:r>
               <a:rPr lang="en-US" sz="1450" dirty="0">
                 <a:solidFill>
-                  <a:srgbClr val="9FBBB2"/>
+                  <a:srgbClr val="93AAC0"/>
                 </a:solidFill>
               </a:rPr>
               <a:t>SEAD/PROUrbe (lista do programa estadual — é o que decide alvo), RFB (adesões e remessas no PI), SEFAZ-PI (repasse do IBS), TCE-PI (preço praticado).</a:t>
@@ -3282,7 +3282,7 @@
             <a:r>
               <a:rPr lang="en-US" sz="1450" b="1" dirty="0">
                 <a:solidFill>
-                  <a:srgbClr val="F7F5EE"/>
+                  <a:srgbClr val="F4F6F8"/>
                 </a:solidFill>
               </a:rPr>
               <a:t>Monitorar a Foxinline  —  </a:t>
@@ -3296,7 +3296,7 @@
             <a:r>
               <a:rPr lang="en-US" sz="1450" dirty="0">
                 <a:solidFill>
-                  <a:srgbClr val="9FBBB2"/>
+                  <a:srgbClr val="93AAC0"/>
                 </a:solidFill>
               </a:rPr>
               <a:t>Sem contato antes de remessa aceita: propor parceria agora entrega o roadmap à incumbente. Deck de parceria pronto + monitoramento semanal (site, releases, CT).</a:t>
@@ -3374,7 +3374,7 @@
             <a:r>
               <a:rPr lang="en-US" sz="1450" b="1" dirty="0">
                 <a:solidFill>
-                  <a:srgbClr val="F7F5EE"/>
+                  <a:srgbClr val="F4F6F8"/>
                 </a:solidFill>
               </a:rPr>
               <a:t>Fechar o piloto com o proponente  —  </a:t>
@@ -3388,7 +3388,7 @@
             <a:r>
               <a:rPr lang="en-US" sz="1450" dirty="0">
                 <a:solidFill>
-                  <a:srgbClr val="9FBBB2"/>
+                  <a:srgbClr val="93AAC0"/>
                 </a:solidFill>
               </a:rPr>
               <a:t>Definir o município-alvo (interior com base Reurb), a premissa “dado público + coleta própria” e a meta de remessa aceita.</a:t>
@@ -3466,7 +3466,7 @@
             <a:r>
               <a:rPr lang="en-US" sz="1450" b="1" dirty="0">
                 <a:solidFill>
-                  <a:srgbClr val="F7F5EE"/>
+                  <a:srgbClr val="F4F6F8"/>
                 </a:solidFill>
               </a:rPr>
               <a:t>Construir o conector CADURB  —  </a:t>
@@ -3480,7 +3480,7 @@
             <a:r>
               <a:rPr lang="en-US" sz="1450" dirty="0">
                 <a:solidFill>
-                  <a:srgbClr val="9FBBB2"/>
+                  <a:srgbClr val="93AAC0"/>
                 </a:solidFill>
               </a:rPr>
               <a:t>Swagger público em mãos; pedir credencial de homologação à RFB (sinter.df.cocad@rfb.gov.br) em paralelo.</a:t>
@@ -3539,7 +3539,7 @@
             <a:r>
               <a:rPr lang="en-US" sz="1150" dirty="0">
                 <a:solidFill>
-                  <a:srgbClr val="9FBBB2"/>
+                  <a:srgbClr val="93AAC0"/>
                 </a:solidFill>
               </a:rPr>
               <a:t>Análise completa: analise/26-relatorio-sessao-zcode.md e analise/PLANO.md · Painel: painel/index.html</a:t>
@@ -3607,7 +3607,7 @@
             <a:r>
               <a:rPr lang="en-US" sz="3000" b="1" dirty="0">
                 <a:solidFill>
-                  <a:srgbClr val="20261F"/>
+                  <a:srgbClr val="0B2545"/>
                 </a:solidFill>
                 <a:latin typeface="Georgia" pitchFamily="34" charset="0"/>
                 <a:ea typeface="Georgia" pitchFamily="34" charset="-122"/>
@@ -3640,7 +3640,7 @@
           </a:solidFill>
           <a:ln w="9525">
             <a:solidFill>
-              <a:srgbClr val="D9D4C4"/>
+              <a:srgbClr val="E2E6EA"/>
             </a:solidFill>
             <a:prstDash val="solid"/>
           </a:ln>
@@ -3673,7 +3673,7 @@
             <a:r>
               <a:rPr lang="en-US" sz="6000" b="1" dirty="0">
                 <a:solidFill>
-                  <a:srgbClr val="B14B34"/>
+                  <a:srgbClr val="C03A24"/>
                 </a:solidFill>
                 <a:latin typeface="Georgia" pitchFamily="34" charset="0"/>
                 <a:ea typeface="Georgia" pitchFamily="34" charset="-122"/>
@@ -3712,7 +3712,7 @@
             <a:r>
               <a:rPr lang="en-US" sz="1550" b="1" dirty="0">
                 <a:solidFill>
-                  <a:srgbClr val="20261F"/>
+                  <a:srgbClr val="0B2545"/>
                 </a:solidFill>
               </a:rPr>
               <a:t>endpoints públicos de API no CERURB</a:t>
@@ -3751,7 +3751,7 @@
             <a:r>
               <a:rPr lang="en-US" sz="1250" dirty="0">
                 <a:solidFill>
-                  <a:srgbClr val="6E7266"/>
+                  <a:srgbClr val="5B6B7A"/>
                 </a:solidFill>
               </a:rPr>
               <a:t>Toda a base do sistema é interna e protegida por cláusula de sigilo. O caminho é parceria formal — não integração técnica.</a:t>
@@ -3777,11 +3777,11 @@
             </a:avLst>
           </a:prstGeom>
           <a:solidFill>
-            <a:srgbClr val="E4EBE7"/>
+            <a:srgbClr val="EDF1F5"/>
           </a:solidFill>
           <a:ln w="9525">
             <a:solidFill>
-              <a:srgbClr val="D9D4C4"/>
+              <a:srgbClr val="E2E6EA"/>
             </a:solidFill>
             <a:prstDash val="solid"/>
           </a:ln>
@@ -3814,7 +3814,7 @@
             <a:r>
               <a:rPr lang="en-US" sz="6000" b="1" dirty="0">
                 <a:solidFill>
-                  <a:srgbClr val="17453D"/>
+                  <a:srgbClr val="0B2545"/>
                 </a:solidFill>
                 <a:latin typeface="Georgia" pitchFamily="34" charset="0"/>
                 <a:ea typeface="Georgia" pitchFamily="34" charset="-122"/>
@@ -3853,7 +3853,7 @@
             <a:r>
               <a:rPr lang="en-US" sz="1550" b="1" dirty="0">
                 <a:solidFill>
-                  <a:srgbClr val="20261F"/>
+                  <a:srgbClr val="0B2545"/>
                 </a:solidFill>
               </a:rPr>
               <a:t>campos do painel existem hoje em dado público por bairro</a:t>
@@ -3892,7 +3892,7 @@
             <a:r>
               <a:rPr lang="en-US" sz="1250" dirty="0">
                 <a:solidFill>
-                  <a:srgbClr val="6E7266"/>
+                  <a:srgbClr val="5B6B7A"/>
                 </a:solidFill>
               </a:rPr>
               <a:t>IBGE Censo 2022 (renda, água, esgoto, pavimentação, iluminação, demografia) + INEP + ANEEL + TCE-PI.</a:t>
@@ -3922,7 +3922,7 @@
           </a:solidFill>
           <a:ln w="9525">
             <a:solidFill>
-              <a:srgbClr val="D9D4C4"/>
+              <a:srgbClr val="E2E6EA"/>
             </a:solidFill>
             <a:prstDash val="solid"/>
           </a:ln>
@@ -3994,7 +3994,7 @@
             <a:r>
               <a:rPr lang="en-US" sz="1550" b="1" dirty="0">
                 <a:solidFill>
-                  <a:srgbClr val="20261F"/>
+                  <a:srgbClr val="0B2545"/>
                 </a:solidFill>
               </a:rPr>
               <a:t>dias até 31/12/2026 — prazo de integração ao CIB/Sinter</a:t>
@@ -4033,7 +4033,7 @@
             <a:r>
               <a:rPr lang="en-US" sz="1250" dirty="0">
                 <a:solidFill>
-                  <a:srgbClr val="6E7266"/>
+                  <a:srgbClr val="5B6B7A"/>
                 </a:solidFill>
               </a:rPr>
               <a:t>188 de 5.570 municípios transmitiram cadastro. No PI, apenas Teresina. A janela prática de contratação é nov–dez.</a:t>
@@ -4069,7 +4069,7 @@
             <a:r>
               <a:rPr lang="en-US" sz="1050" dirty="0">
                 <a:solidFill>
-                  <a:srgbClr val="6E7266"/>
+                  <a:srgbClr val="5B6B7A"/>
                 </a:solidFill>
               </a:rPr>
               <a:t>Verificações em fonte primária: FTP/IBGE, cerurbjus.tjpi.jus.br, contrato TJ-PI 156/2023 (PNCP), RFB/Sinter — 15 e 16/09/2026.</a:t>
@@ -4105,7 +4105,7 @@
             <a:r>
               <a:rPr lang="en-US" sz="1100" dirty="0">
                 <a:solidFill>
-                  <a:srgbClr val="6E7266"/>
+                  <a:srgbClr val="5B6B7A"/>
                 </a:solidFill>
               </a:rPr>
               <a:t>02</a:t>
@@ -4173,7 +4173,7 @@
             <a:r>
               <a:rPr lang="en-US" sz="3000" b="1" dirty="0">
                 <a:solidFill>
-                  <a:srgbClr val="20261F"/>
+                  <a:srgbClr val="0B2545"/>
                 </a:solidFill>
                 <a:latin typeface="Georgia" pitchFamily="34" charset="0"/>
                 <a:ea typeface="Georgia" pitchFamily="34" charset="-122"/>
@@ -4212,7 +4212,7 @@
             <a:r>
               <a:rPr lang="en-US" sz="1400" dirty="0">
                 <a:solidFill>
-                  <a:srgbClr val="6E7266"/>
+                  <a:srgbClr val="5B6B7A"/>
                 </a:solidFill>
               </a:rPr>
               <a:t>Geometria oficial dos 123 bairros (IBGE CD 2022) no lugar da grade ilustrativa — e a mesma leitura estendida aos 25 municípios do PI que têm bairros.</a:t>
@@ -4279,7 +4279,7 @@
             <a:r>
               <a:rPr lang="en-US" sz="2100" b="1" dirty="0">
                 <a:solidFill>
-                  <a:srgbClr val="20261F"/>
+                  <a:srgbClr val="0B2545"/>
                 </a:solidFill>
                 <a:latin typeface="Georgia" pitchFamily="34" charset="0"/>
                 <a:ea typeface="Georgia" pitchFamily="34" charset="-122"/>
@@ -4322,7 +4322,7 @@
             <a:r>
               <a:rPr lang="en-US" sz="1350" dirty="0">
                 <a:solidFill>
-                  <a:srgbClr val="20261F"/>
+                  <a:srgbClr val="0B2545"/>
                 </a:solidFill>
               </a:rPr>
               <a:t>Grade ilustrativa → coroplético com a malha oficial dos 123 bairros do IBGE (CD 2022)</a:t>
@@ -4340,7 +4340,7 @@
             <a:r>
               <a:rPr lang="en-US" sz="1350" dirty="0">
                 <a:solidFill>
-                  <a:srgbClr val="20261F"/>
+                  <a:srgbClr val="0B2545"/>
                 </a:solidFill>
               </a:rPr>
               <a:t>Dados fictícios → onze indicadores reais por bairro: renda mediana, esgoto, água, pavimentação, iluminação, calçada, bueiro, rampa, arborização e faixas etárias</a:t>
@@ -4358,7 +4358,7 @@
             <a:r>
               <a:rPr lang="en-US" sz="1350" dirty="0">
                 <a:solidFill>
-                  <a:srgbClr val="20261F"/>
+                  <a:srgbClr val="0B2545"/>
                 </a:solidFill>
               </a:rPr>
               <a:t>18 bairros simulados → 479 bairros reais em 25 municípios, com ranking e cruzamento renda × esgoto</a:t>
@@ -4376,7 +4376,7 @@
             <a:r>
               <a:rPr lang="en-US" sz="1350" dirty="0">
                 <a:solidFill>
-                  <a:srgbClr val="20261F"/>
+                  <a:srgbClr val="0B2545"/>
                 </a:solidFill>
               </a:rPr>
               <a:t>Zero negociações institucionais para montar esta tela — 100% dado aberto baixado do FTP do IBGE</a:t>
@@ -4394,7 +4394,7 @@
             <a:r>
               <a:rPr lang="en-US" sz="1350" dirty="0">
                 <a:solidFill>
-                  <a:srgbClr val="20261F"/>
+                  <a:srgbClr val="0B2545"/>
                 </a:solidFill>
               </a:rPr>
               <a:t>Arquivo: painel/index.html — servido localmente por python3 -m http.server, sem internet</a:t>
@@ -4430,7 +4430,7 @@
             <a:r>
               <a:rPr lang="en-US" sz="1050" dirty="0">
                 <a:solidFill>
-                  <a:srgbClr val="6E7266"/>
+                  <a:srgbClr val="5B6B7A"/>
                 </a:solidFill>
               </a:rPr>
               <a:t>Fonte: IBGE, Censo 2022 — agregados por bairros (características de domicílio, entorno, rendimento do responsável) e malha de bairros CD 2022.</a:t>
@@ -4466,7 +4466,7 @@
             <a:r>
               <a:rPr lang="en-US" sz="1100" dirty="0">
                 <a:solidFill>
-                  <a:srgbClr val="6E7266"/>
+                  <a:srgbClr val="5B6B7A"/>
                 </a:solidFill>
               </a:rPr>
               <a:t>03</a:t>
@@ -4534,7 +4534,7 @@
             <a:r>
               <a:rPr lang="en-US" sz="3000" b="1" dirty="0">
                 <a:solidFill>
-                  <a:srgbClr val="20261F"/>
+                  <a:srgbClr val="0B2545"/>
                 </a:solidFill>
                 <a:latin typeface="Georgia" pitchFamily="34" charset="0"/>
                 <a:ea typeface="Georgia" pitchFamily="34" charset="-122"/>
@@ -4573,7 +4573,7 @@
             <a:r>
               <a:rPr lang="en-US" sz="1400" dirty="0">
                 <a:solidFill>
-                  <a:srgbClr val="6E7266"/>
+                  <a:srgbClr val="5B6B7A"/>
                 </a:solidFill>
               </a:rPr>
               <a:t>Renda mediana dos responsáveis × cobertura de esgoto em rede, por bairro — os dois eixos do painel, em dado aberto.</a:t>
@@ -4640,7 +4640,7 @@
             <a:r>
               <a:rPr lang="en-US" sz="3000" b="1" dirty="0">
                 <a:solidFill>
-                  <a:srgbClr val="B14B34"/>
+                  <a:srgbClr val="C03A24"/>
                 </a:solidFill>
                 <a:latin typeface="Georgia" pitchFamily="34" charset="0"/>
                 <a:ea typeface="Georgia" pitchFamily="34" charset="-122"/>
@@ -4682,7 +4682,7 @@
             <a:r>
               <a:rPr lang="en-US" sz="1250" dirty="0">
                 <a:solidFill>
-                  <a:srgbClr val="6E7266"/>
+                  <a:srgbClr val="5B6B7A"/>
                 </a:solidFill>
               </a:rPr>
               <a:t>dos domicílios com esgoto em rede — média municipal ponderada</a:t>
@@ -4718,7 +4718,7 @@
             <a:r>
               <a:rPr lang="en-US" sz="3000" b="1" dirty="0">
                 <a:solidFill>
-                  <a:srgbClr val="17453D"/>
+                  <a:srgbClr val="0B2545"/>
                 </a:solidFill>
                 <a:latin typeface="Georgia" pitchFamily="34" charset="0"/>
                 <a:ea typeface="Georgia" pitchFamily="34" charset="-122"/>
@@ -4760,7 +4760,7 @@
             <a:r>
               <a:rPr lang="en-US" sz="1250" dirty="0">
                 <a:solidFill>
-                  <a:srgbClr val="6E7266"/>
+                  <a:srgbClr val="5B6B7A"/>
                 </a:solidFill>
               </a:rPr>
               <a:t>renda mediana mensal do responsável em Teresina — Tabajaras R$ 15.000 × Chapadinha R$ 1.200</a:t>
@@ -4838,7 +4838,7 @@
             <a:r>
               <a:rPr lang="en-US" sz="1250" dirty="0">
                 <a:solidFill>
-                  <a:srgbClr val="6E7266"/>
+                  <a:srgbClr val="5B6B7A"/>
                 </a:solidFill>
               </a:rPr>
               <a:t>e Triunfo: 0% de esgoto em rede, 509 domicílios somados — o ranking real aponta onde intervir</a:t>
@@ -4874,7 +4874,7 @@
             <a:r>
               <a:rPr lang="en-US" sz="1050" dirty="0">
                 <a:solidFill>
-                  <a:srgbClr val="6E7266"/>
+                  <a:srgbClr val="5B6B7A"/>
                 </a:solidFill>
               </a:rPr>
               <a:t>Fonte: IBGE Censo 2022, agregados por bairros (V00309/V00001; V06006 — mediana, não média) — médias ponderadas por domicílios ocupados.</a:t>
@@ -4910,7 +4910,7 @@
             <a:r>
               <a:rPr lang="en-US" sz="1100" dirty="0">
                 <a:solidFill>
-                  <a:srgbClr val="6E7266"/>
+                  <a:srgbClr val="5B6B7A"/>
                 </a:solidFill>
               </a:rPr>
               <a:t>04</a:t>
@@ -4978,7 +4978,7 @@
             <a:r>
               <a:rPr lang="en-US" sz="3000" b="1" dirty="0">
                 <a:solidFill>
-                  <a:srgbClr val="20261F"/>
+                  <a:srgbClr val="0B2545"/>
                 </a:solidFill>
                 <a:latin typeface="Georgia" pitchFamily="34" charset="0"/>
                 <a:ea typeface="Georgia" pitchFamily="34" charset="-122"/>
@@ -5017,7 +5017,7 @@
             <a:r>
               <a:rPr lang="en-US" sz="1400" dirty="0">
                 <a:solidFill>
-                  <a:srgbClr val="6E7266"/>
+                  <a:srgbClr val="5B6B7A"/>
                 </a:solidFill>
               </a:rPr>
               <a:t>As negociações institucionais da matriz caíram de 5 para 2 — o restante é dado aberto ou coleta própria.</a:t>
@@ -5043,11 +5043,11 @@
             </a:avLst>
           </a:prstGeom>
           <a:solidFill>
-            <a:srgbClr val="E4EBE7"/>
+            <a:srgbClr val="EDF1F5"/>
           </a:solidFill>
           <a:ln w="9525">
             <a:solidFill>
-              <a:srgbClr val="D9D4C4"/>
+              <a:srgbClr val="E2E6EA"/>
             </a:solidFill>
             <a:prstDash val="solid"/>
           </a:ln>
@@ -5080,7 +5080,7 @@
             <a:r>
               <a:rPr lang="en-US" sz="1500" b="1" dirty="0">
                 <a:solidFill>
-                  <a:srgbClr val="17453D"/>
+                  <a:srgbClr val="0B2545"/>
                 </a:solidFill>
               </a:rPr>
               <a:t>CAMADA PÚBLICA — hoje, sem nenhum ofício</a:t>
@@ -5120,7 +5120,7 @@
             <a:r>
               <a:rPr lang="en-US" sz="1200" dirty="0">
                 <a:solidFill>
-                  <a:srgbClr val="20261F"/>
+                  <a:srgbClr val="0B2545"/>
                 </a:solidFill>
               </a:rPr>
               <a:t>IBGE por bairro: renda, água, esgoto, pavimentação, iluminação, demografia, favelas (vetores)</a:t>
@@ -5138,7 +5138,7 @@
             <a:r>
               <a:rPr lang="en-US" sz="1200" dirty="0">
                 <a:solidFill>
-                  <a:srgbClr val="20261F"/>
+                  <a:srgbClr val="0B2545"/>
                 </a:solidFill>
               </a:rPr>
               <a:t>INEP por escola · ANEEL geração solar · TCE-PI e SICONFI (fiscal) · SINISA (saneamento) · DataJud (processos)</a:t>
@@ -5156,7 +5156,7 @@
             <a:r>
               <a:rPr lang="en-US" sz="1200" dirty="0">
                 <a:solidFill>
-                  <a:srgbClr val="20261F"/>
+                  <a:srgbClr val="0B2545"/>
                 </a:solidFill>
               </a:rPr>
               <a:t>Geometria oficial dos bairros + SEMPLAN + ESRI/OSM como base cartográfica</a:t>
@@ -5186,7 +5186,7 @@
           </a:solidFill>
           <a:ln w="9525">
             <a:solidFill>
-              <a:srgbClr val="D9D4C4"/>
+              <a:srgbClr val="E2E6EA"/>
             </a:solidFill>
             <a:prstDash val="solid"/>
           </a:ln>
@@ -5259,7 +5259,7 @@
             <a:r>
               <a:rPr lang="en-US" sz="1200" dirty="0">
                 <a:solidFill>
-                  <a:srgbClr val="20261F"/>
+                  <a:srgbClr val="0B2545"/>
                 </a:solidFill>
               </a:rPr>
               <a:t>Concessionária de saneamento: série atualizada de cobertura e rede física</a:t>
@@ -5277,7 +5277,7 @@
             <a:r>
               <a:rPr lang="en-US" sz="1200" dirty="0">
                 <a:solidFill>
-                  <a:srgbClr val="20261F"/>
+                  <a:srgbClr val="0B2545"/>
                 </a:solidFill>
               </a:rPr>
               <a:t>ETURB: base Reurb georreferenciada (núcleos, títulos entregues)</a:t>
@@ -5295,7 +5295,7 @@
             <a:r>
               <a:rPr lang="en-US" sz="1200" dirty="0">
                 <a:solidFill>
-                  <a:srgbClr val="20261F"/>
+                  <a:srgbClr val="0B2545"/>
                 </a:solidFill>
               </a:rPr>
               <a:t>Prazo legal: resposta em 15 dias + 10 de prorrogação (LAI)</a:t>
@@ -5325,7 +5325,7 @@
           </a:solidFill>
           <a:ln w="9525">
             <a:solidFill>
-              <a:srgbClr val="D9D4C4"/>
+              <a:srgbClr val="E2E6EA"/>
             </a:solidFill>
             <a:prstDash val="solid"/>
           </a:ln>
@@ -5358,7 +5358,7 @@
             <a:r>
               <a:rPr lang="en-US" sz="1500" b="1" dirty="0">
                 <a:solidFill>
-                  <a:srgbClr val="B14B34"/>
+                  <a:srgbClr val="C03A24"/>
                 </a:solidFill>
               </a:rPr>
               <a:t>CAMADA COLETA PRÓPRIA — o diferencial</a:t>
@@ -5398,7 +5398,7 @@
             <a:r>
               <a:rPr lang="en-US" sz="1200" dirty="0">
                 <a:solidFill>
-                  <a:srgbClr val="20261F"/>
+                  <a:srgbClr val="0B2545"/>
                 </a:solidFill>
               </a:rPr>
               <a:t>Tipo de posse, status processual, família, saúde, avaliação do imóvel</a:t>
@@ -5416,7 +5416,7 @@
             <a:r>
               <a:rPr lang="en-US" sz="1200" dirty="0">
                 <a:solidFill>
-                  <a:srgbClr val="20261F"/>
+                  <a:srgbClr val="0B2545"/>
                 </a:solidFill>
               </a:rPr>
               <a:t>Saída interoperável: SHP/UTM + memorial — compatível com cartório, TJ e CIB/Sinter</a:t>
@@ -5434,7 +5434,7 @@
             <a:r>
               <a:rPr lang="en-US" sz="1200" dirty="0">
                 <a:solidFill>
-                  <a:srgbClr val="20261F"/>
+                  <a:srgbClr val="0B2545"/>
                 </a:solidFill>
               </a:rPr>
               <a:t>Município como controlador (LGPD); nós como operadores do contrato</a:t>
@@ -5470,7 +5470,7 @@
             <a:r>
               <a:rPr lang="en-US" sz="1050" dirty="0">
                 <a:solidFill>
-                  <a:srgbClr val="6E7266"/>
+                  <a:srgbClr val="5B6B7A"/>
                 </a:solidFill>
               </a:rPr>
               <a:t>CERURB (Foxinline/TJ-PI): sem API pública — acesso apenas via convênio, cláusula 4.1.1 do contrato TJ-PI, e-SIC ou negociação direta.</a:t>
@@ -5506,7 +5506,7 @@
             <a:r>
               <a:rPr lang="en-US" sz="1100" dirty="0">
                 <a:solidFill>
-                  <a:srgbClr val="6E7266"/>
+                  <a:srgbClr val="5B6B7A"/>
                 </a:solidFill>
               </a:rPr>
               <a:t>05</a:t>
@@ -5574,7 +5574,7 @@
             <a:r>
               <a:rPr lang="en-US" sz="3000" b="1" dirty="0">
                 <a:solidFill>
-                  <a:srgbClr val="20261F"/>
+                  <a:srgbClr val="0B2545"/>
                 </a:solidFill>
                 <a:latin typeface="Georgia" pitchFamily="34" charset="0"/>
                 <a:ea typeface="Georgia" pitchFamily="34" charset="-122"/>
@@ -5616,7 +5616,7 @@
             <a:r>
               <a:rPr lang="en-US" sz="1700" b="1" dirty="0">
                 <a:solidFill>
-                  <a:srgbClr val="17453D"/>
+                  <a:srgbClr val="0B2545"/>
                 </a:solidFill>
               </a:rPr>
               <a:t>O que constatamos</a:t>
@@ -5643,7 +5643,7 @@
             <a:r>
               <a:rPr lang="en-US" sz="1350" dirty="0">
                 <a:solidFill>
-                  <a:srgbClr val="20261F"/>
+                  <a:srgbClr val="0B2545"/>
                 </a:solidFill>
               </a:rPr>
               <a:t>Sistema Java/JSF do TJ-PI (CERURBJus) — sem endpoints públicos (testados: todos 404)</a:t>
@@ -5661,7 +5661,7 @@
             <a:r>
               <a:rPr lang="en-US" sz="1350" dirty="0">
                 <a:solidFill>
-                  <a:srgbClr val="20261F"/>
+                  <a:srgbClr val="0B2545"/>
                 </a:solidFill>
               </a:rPr>
               <a:t>Contrato 156/2023 com cláusula de sigilo: vedado repasse de dados a terceiros</a:t>
@@ -5679,7 +5679,7 @@
             <a:r>
               <a:rPr lang="en-US" sz="1350" dirty="0">
                 <a:solidFill>
-                  <a:srgbClr val="20261F"/>
+                  <a:srgbClr val="0B2545"/>
                 </a:solidFill>
               </a:rPr>
               <a:t>Escala real da Foxinline: 307 subdomínios, tenants em 6 estados, 2 tribunais (TJ-PI e TJ-MT)</a:t>
@@ -5697,7 +5697,7 @@
             <a:r>
               <a:rPr lang="en-US" sz="1350" dirty="0">
                 <a:solidFill>
-                  <a:srgbClr val="20261F"/>
+                  <a:srgbClr val="0B2545"/>
                 </a:solidFill>
               </a:rPr>
               <a:t>Scraping/playwright não é rota: dado pessoal sensível (LGPD) + rastro auditável sob o CPF da conta</a:t>
@@ -5763,7 +5763,7 @@
             <a:r>
               <a:rPr lang="en-US" sz="1350" dirty="0">
                 <a:solidFill>
-                  <a:srgbClr val="20261F"/>
+                  <a:srgbClr val="0B2545"/>
                 </a:solidFill>
               </a:rPr>
               <a:t>Cláusula 4.1.1: o TJ-PI pode autorizar uso por outros órgãos — porta para acesso municipal</a:t>
@@ -5781,7 +5781,7 @@
             <a:r>
               <a:rPr lang="en-US" sz="1350" dirty="0">
                 <a:solidFill>
-                  <a:srgbClr val="20261F"/>
+                  <a:srgbClr val="0B2545"/>
                 </a:solidFill>
               </a:rPr>
               <a:t>e-SIC ao TJ-PI/SEAD para dados agregados; DataJud/PJe para métricas processuais (público)</a:t>
@@ -5799,7 +5799,7 @@
             <a:r>
               <a:rPr lang="en-US" sz="1350" dirty="0">
                 <a:solidFill>
-                  <a:srgbClr val="20261F"/>
+                  <a:srgbClr val="0B2545"/>
                 </a:solidFill>
               </a:rPr>
               <a:t>Negociação direta com a Foxinline (contatos mapeados) — parceira fundiária em potencial</a:t>
@@ -5817,7 +5817,7 @@
             <a:r>
               <a:rPr lang="en-US" sz="1350" dirty="0">
                 <a:solidFill>
-                  <a:srgbClr val="20261F"/>
+                  <a:srgbClr val="0B2545"/>
                 </a:solidFill>
               </a:rPr>
               <a:t>A conta criada serve para inteligência (modelos e campos do formulário), não para extração</a:t>
@@ -5843,7 +5843,7 @@
           <a:noFill/>
           <a:ln w="12700">
             <a:solidFill>
-              <a:srgbClr val="D9D4C4"/>
+              <a:srgbClr val="E2E6EA"/>
             </a:solidFill>
             <a:prstDash val="solid"/>
           </a:ln>
@@ -5876,7 +5876,7 @@
             <a:r>
               <a:rPr lang="en-US" sz="1050" dirty="0">
                 <a:solidFill>
-                  <a:srgbClr val="6E7266"/>
+                  <a:srgbClr val="5B6B7A"/>
                 </a:solidFill>
               </a:rPr>
               <a:t>Fontes: cerurbjus.tjpi.jus.br (inspeção passiva 15/09/2026); contrato TJ-PI 156/2023 e TR SEAD-PI (PNCP); crt.sh (Certificate Transparency).</a:t>
@@ -5912,7 +5912,7 @@
             <a:r>
               <a:rPr lang="en-US" sz="1100" dirty="0">
                 <a:solidFill>
-                  <a:srgbClr val="6E7266"/>
+                  <a:srgbClr val="5B6B7A"/>
                 </a:solidFill>
               </a:rPr>
               <a:t>06</a:t>
@@ -5980,7 +5980,7 @@
             <a:r>
               <a:rPr lang="en-US" sz="3000" b="1" dirty="0">
                 <a:solidFill>
-                  <a:srgbClr val="20261F"/>
+                  <a:srgbClr val="0B2545"/>
                 </a:solidFill>
                 <a:latin typeface="Georgia" pitchFamily="34" charset="0"/>
                 <a:ea typeface="Georgia" pitchFamily="34" charset="-122"/>
@@ -6035,7 +6035,7 @@
             <a:r>
               <a:rPr lang="en-US" sz="6400" b="1" dirty="0">
                 <a:solidFill>
-                  <a:srgbClr val="B14B34"/>
+                  <a:srgbClr val="C03A24"/>
                 </a:solidFill>
                 <a:latin typeface="Georgia" pitchFamily="34" charset="0"/>
                 <a:ea typeface="Georgia" pitchFamily="34" charset="-122"/>
@@ -6077,7 +6077,7 @@
             <a:r>
               <a:rPr lang="en-US" sz="1300" dirty="0">
                 <a:solidFill>
-                  <a:srgbClr val="6E7266"/>
+                  <a:srgbClr val="5B6B7A"/>
                 </a:solidFill>
               </a:rPr>
               <a:t>municípios com CIB ativo no Brasil — 3,4% dos 5.570. Adesão é papel; transmissão é a parede.</a:t>
@@ -6155,7 +6155,7 @@
             <a:r>
               <a:rPr lang="en-US" sz="1300" dirty="0">
                 <a:solidFill>
-                  <a:srgbClr val="6E7266"/>
+                  <a:srgbClr val="5B6B7A"/>
                 </a:solidFill>
               </a:rPr>
               <a:t>município do PI transmitiu: Teresina (363.805 CIBs). Os outros 223 — incluindo os com base Reurb — não têm nada.</a:t>
@@ -6191,7 +6191,7 @@
             <a:r>
               <a:rPr lang="en-US" sz="1050" dirty="0">
                 <a:solidFill>
-                  <a:srgbClr val="6E7266"/>
+                  <a:srgbClr val="5B6B7A"/>
                 </a:solidFill>
               </a:rPr>
               <a:t>Fonte: RFB/Sinter — inscrições ativas por município, corte de 15/09/2026 (inscricoes_ativas_setembro_2026_2.csv).</a:t>
@@ -6227,7 +6227,7 @@
             <a:r>
               <a:rPr lang="en-US" sz="1100" dirty="0">
                 <a:solidFill>
-                  <a:srgbClr val="6E7266"/>
+                  <a:srgbClr val="5B6B7A"/>
                 </a:solidFill>
               </a:rPr>
               <a:t>07</a:t>
@@ -6295,7 +6295,7 @@
             <a:r>
               <a:rPr lang="en-US" sz="3000" b="1" dirty="0">
                 <a:solidFill>
-                  <a:srgbClr val="20261F"/>
+                  <a:srgbClr val="0B2545"/>
                 </a:solidFill>
                 <a:latin typeface="Georgia" pitchFamily="34" charset="0"/>
                 <a:ea typeface="Georgia" pitchFamily="34" charset="-122"/>
@@ -6322,7 +6322,7 @@
             <a:avLst/>
           </a:prstGeom>
           <a:solidFill>
-            <a:srgbClr val="17453D"/>
+            <a:srgbClr val="0B2545"/>
           </a:solidFill>
           <a:ln w="25400">
             <a:solidFill>
@@ -6388,7 +6388,7 @@
           <a:noFill/>
           <a:ln w="19050">
             <a:solidFill>
-              <a:srgbClr val="D9D4C4"/>
+              <a:srgbClr val="E2E6EA"/>
             </a:solidFill>
             <a:prstDash val="dash"/>
           </a:ln>
@@ -6457,7 +6457,7 @@
             <a:r>
               <a:rPr lang="en-US" sz="1900" b="1" dirty="0">
                 <a:solidFill>
-                  <a:srgbClr val="20261F"/>
+                  <a:srgbClr val="0B2545"/>
                 </a:solidFill>
                 <a:latin typeface="Georgia" pitchFamily="34" charset="0"/>
                 <a:ea typeface="Georgia" pitchFamily="34" charset="-122"/>
@@ -6499,7 +6499,7 @@
             <a:r>
               <a:rPr lang="en-US" sz="1200" dirty="0">
                 <a:solidFill>
-                  <a:srgbClr val="6E7266"/>
+                  <a:srgbClr val="5B6B7A"/>
                 </a:solidFill>
               </a:rPr>
               <a:t>Swagger de homologação público (manual ENAT v1.12); token OAuth via adesão gratuita. Construir antes de qualquer cliente.</a:t>
@@ -6523,7 +6523,7 @@
             <a:avLst/>
           </a:prstGeom>
           <a:solidFill>
-            <a:srgbClr val="17453D"/>
+            <a:srgbClr val="0B2545"/>
           </a:solidFill>
           <a:ln w="25400">
             <a:solidFill>
@@ -6589,7 +6589,7 @@
           <a:noFill/>
           <a:ln w="19050">
             <a:solidFill>
-              <a:srgbClr val="D9D4C4"/>
+              <a:srgbClr val="E2E6EA"/>
             </a:solidFill>
             <a:prstDash val="dash"/>
           </a:ln>
@@ -6658,7 +6658,7 @@
             <a:r>
               <a:rPr lang="en-US" sz="1900" b="1" dirty="0">
                 <a:solidFill>
-                  <a:srgbClr val="20261F"/>
+                  <a:srgbClr val="0B2545"/>
                 </a:solidFill>
                 <a:latin typeface="Georgia" pitchFamily="34" charset="0"/>
                 <a:ea typeface="Georgia" pitchFamily="34" charset="-122"/>
@@ -6700,7 +6700,7 @@
             <a:r>
               <a:rPr lang="en-US" sz="1200" dirty="0">
                 <a:solidFill>
-                  <a:srgbClr val="6E7266"/>
+                  <a:srgbClr val="5B6B7A"/>
                 </a:solidFill>
               </a:rPr>
               <a:t>Lista dos 224 municípios do PI já qualificada; priorizar quem tem base Reurb georreferenciada, não tem incumbente e falha no RREO. Diagnóstico como porta de entrada.</a:t>
@@ -6724,7 +6724,7 @@
             <a:avLst/>
           </a:prstGeom>
           <a:solidFill>
-            <a:srgbClr val="17453D"/>
+            <a:srgbClr val="0B2545"/>
           </a:solidFill>
           <a:ln w="25400">
             <a:solidFill>
@@ -6790,7 +6790,7 @@
           <a:noFill/>
           <a:ln w="19050">
             <a:solidFill>
-              <a:srgbClr val="D9D4C4"/>
+              <a:srgbClr val="E2E6EA"/>
             </a:solidFill>
             <a:prstDash val="dash"/>
           </a:ln>
@@ -6859,7 +6859,7 @@
             <a:r>
               <a:rPr lang="en-US" sz="1900" b="1" dirty="0">
                 <a:solidFill>
-                  <a:srgbClr val="20261F"/>
+                  <a:srgbClr val="0B2545"/>
                 </a:solidFill>
                 <a:latin typeface="Georgia" pitchFamily="34" charset="0"/>
                 <a:ea typeface="Georgia" pitchFamily="34" charset="-122"/>
@@ -6901,7 +6901,7 @@
             <a:r>
               <a:rPr lang="en-US" sz="1200" dirty="0">
                 <a:solidFill>
-                  <a:srgbClr val="6E7266"/>
+                  <a:srgbClr val="5B6B7A"/>
                 </a:solidFill>
               </a:rPr>
               <a:t>Contratos por dispensa com SLA condicional: remessa ACEITA em homologação se a base chegar até 30/11.</a:t>
@@ -6925,7 +6925,7 @@
             <a:avLst/>
           </a:prstGeom>
           <a:solidFill>
-            <a:srgbClr val="B14B34"/>
+            <a:srgbClr val="C03A24"/>
           </a:solidFill>
           <a:ln w="25400">
             <a:solidFill>
@@ -7037,7 +7037,7 @@
             <a:r>
               <a:rPr lang="en-US" sz="1900" b="1" dirty="0">
                 <a:solidFill>
-                  <a:srgbClr val="20261F"/>
+                  <a:srgbClr val="0B2545"/>
                 </a:solidFill>
                 <a:latin typeface="Georgia" pitchFamily="34" charset="0"/>
                 <a:ea typeface="Georgia" pitchFamily="34" charset="-122"/>
@@ -7079,7 +7079,7 @@
             <a:r>
               <a:rPr lang="en-US" sz="1200" dirty="0">
                 <a:solidFill>
-                  <a:srgbClr val="6E7266"/>
+                  <a:srgbClr val="5B6B7A"/>
                 </a:solidFill>
               </a:rPr>
               <a:t>Meta: 2–3 contratos até 15/11; 3–5 remessas aceitas é o cenário otimista, condicionado ao conector. Empenho de 2026 em nov–dez.</a:t>
@@ -7115,7 +7115,7 @@
             <a:r>
               <a:rPr lang="en-US" sz="1250" dirty="0">
                 <a:solidFill>
-                  <a:srgbClr val="17453D"/>
+                  <a:srgbClr val="0B2545"/>
                 </a:solidFill>
               </a:rPr>
               <a:t>Capacidade estimada: ~2 contas/mês artesanal; 10–20/mês com conector — mas o gargalo real é o saneamento do cadastro, por isso pilotos onde a base já existe.</a:t>
@@ -7151,7 +7151,7 @@
             <a:r>
               <a:rPr lang="en-US" sz="1050" dirty="0">
                 <a:solidFill>
-                  <a:srgbClr val="6E7266"/>
+                  <a:srgbClr val="5B6B7A"/>
                 </a:solidFill>
               </a:rPr>
               <a:t>Prazo: LC 214/2025 art. 266 (meta prática de integração 31/12/2026; data legal 16/01/2027). Manual CADURB: ENAT, v1.12/2025.</a:t>
@@ -7187,7 +7187,7 @@
             <a:r>
               <a:rPr lang="en-US" sz="1100" dirty="0">
                 <a:solidFill>
-                  <a:srgbClr val="6E7266"/>
+                  <a:srgbClr val="5B6B7A"/>
                 </a:solidFill>
               </a:rPr>
               <a:t>08</a:t>
@@ -7255,7 +7255,7 @@
             <a:r>
               <a:rPr lang="en-US" sz="3000" b="1" dirty="0">
                 <a:solidFill>
-                  <a:srgbClr val="20261F"/>
+                  <a:srgbClr val="0B2545"/>
                 </a:solidFill>
                 <a:latin typeface="Georgia" pitchFamily="34" charset="0"/>
                 <a:ea typeface="Georgia" pitchFamily="34" charset="-122"/>
@@ -7288,7 +7288,7 @@
           </a:solidFill>
           <a:ln w="9525">
             <a:solidFill>
-              <a:srgbClr val="D9D4C4"/>
+              <a:srgbClr val="E2E6EA"/>
             </a:solidFill>
             <a:prstDash val="solid"/>
           </a:ln>
@@ -7321,7 +7321,7 @@
             <a:r>
               <a:rPr lang="en-US" sz="1600" b="1" dirty="0">
                 <a:solidFill>
-                  <a:srgbClr val="B14B34"/>
+                  <a:srgbClr val="C03A24"/>
                 </a:solidFill>
               </a:rPr>
               <a:t>CENÁRIO PÂNICO  </a:t>
@@ -7332,7 +7332,7 @@
             <a:r>
               <a:rPr lang="en-US" sz="1300" i="1" dirty="0">
                 <a:solidFill>
-                  <a:srgbClr val="6E7266"/>
+                  <a:srgbClr val="5B6B7A"/>
                 </a:solidFill>
               </a:rPr>
               <a:t>prazo mantido</a:t>
@@ -7372,7 +7372,7 @@
             <a:r>
               <a:rPr lang="en-US" sz="1250" dirty="0">
                 <a:solidFill>
-                  <a:srgbClr val="20261F"/>
+                  <a:srgbClr val="0B2545"/>
                 </a:solidFill>
               </a:rPr>
               <a:t>Gatilho: cartório recusa registro sem CIB a partir de jan/2027 — o eleitor liga para a prefeitura, não para a Receita</a:t>
@@ -7390,7 +7390,7 @@
             <a:r>
               <a:rPr lang="en-US" sz="1250" dirty="0">
                 <a:solidFill>
-                  <a:srgbClr val="20261F"/>
+                  <a:srgbClr val="0B2545"/>
                 </a:solidFill>
               </a:rPr>
               <a:t>Gancho: “remessa aceita dentro do prazo, para não perder repasse nem travar registro”</a:t>
@@ -7408,7 +7408,7 @@
             <a:r>
               <a:rPr lang="en-US" sz="1250" dirty="0">
                 <a:solidFill>
-                  <a:srgbClr val="20261F"/>
+                  <a:srgbClr val="0B2545"/>
                 </a:solidFill>
               </a:rPr>
               <a:t>Pacote “regularização em 90 dias” com prêmio de urgência (+20–30%) e lista de espera</a:t>
@@ -7434,11 +7434,11 @@
             </a:avLst>
           </a:prstGeom>
           <a:solidFill>
-            <a:srgbClr val="E4EBE7"/>
+            <a:srgbClr val="EDF1F5"/>
           </a:solidFill>
           <a:ln w="9525">
             <a:solidFill>
-              <a:srgbClr val="D9D4C4"/>
+              <a:srgbClr val="E2E6EA"/>
             </a:solidFill>
             <a:prstDash val="solid"/>
           </a:ln>
@@ -7471,7 +7471,7 @@
             <a:r>
               <a:rPr lang="en-US" sz="1600" b="1" dirty="0">
                 <a:solidFill>
-                  <a:srgbClr val="17453D"/>
+                  <a:srgbClr val="0B2545"/>
                 </a:solidFill>
               </a:rPr>
               <a:t>CENÁRIO PRORROGAÇÃO  </a:t>
@@ -7482,7 +7482,7 @@
             <a:r>
               <a:rPr lang="en-US" sz="1300" i="1" dirty="0">
                 <a:solidFill>
-                  <a:srgbClr val="6E7266"/>
+                  <a:srgbClr val="5B6B7A"/>
                 </a:solidFill>
               </a:rPr>
               <a:t>prazo estendido</a:t>
@@ -7522,7 +7522,7 @@
             <a:r>
               <a:rPr lang="en-US" sz="1250" dirty="0">
                 <a:solidFill>
-                  <a:srgbClr val="20261F"/>
+                  <a:srgbClr val="0B2545"/>
                 </a:solidFill>
               </a:rPr>
               <a:t>Plausível: 97% sem transmissão a meses do fim; LC 214 já alterada duas vezes</a:t>
@@ -7540,7 +7540,7 @@
             <a:r>
               <a:rPr lang="en-US" sz="1250" dirty="0">
                 <a:solidFill>
-                  <a:srgbClr val="20261F"/>
+                  <a:srgbClr val="0B2545"/>
                 </a:solidFill>
               </a:rPr>
               <a:t>Tripwire: monitorar CNM/ABRASF/RFB — se sair, trocar o gancho de “prazo” para “IBS + cartório” em 48h</a:t>
@@ -7558,7 +7558,7 @@
             <a:r>
               <a:rPr lang="en-US" sz="1250" dirty="0">
                 <a:solidFill>
-                  <a:srgbClr val="20261F"/>
+                  <a:srgbClr val="0B2545"/>
                 </a:solidFill>
               </a:rPr>
               <a:t>Venda vira anual: diagnóstico + dashboard + manutenção (o contrato nunca é só a remessa)</a:t>
@@ -7614,7 +7614,7 @@
             <a:r>
               <a:rPr lang="en-US" sz="1300" b="1" dirty="0">
                 <a:solidFill>
-                  <a:srgbClr val="20261F"/>
+                  <a:srgbClr val="0B2545"/>
                 </a:solidFill>
               </a:rPr>
               <a:t>Regra de ouro: </a:t>
@@ -7625,7 +7625,7 @@
             <a:r>
               <a:rPr lang="en-US" sz="1300" dirty="0">
                 <a:solidFill>
-                  <a:srgbClr val="20261F"/>
+                  <a:srgbClr val="0B2545"/>
                 </a:solidFill>
               </a:rPr>
               <a:t>SLA condicional (aceite depende da base chegar em 30/11) e todo contrato inclui o dashboard — assim a prorrogação não zera o valor do piloto.</a:t>
@@ -7661,7 +7661,7 @@
             <a:r>
               <a:rPr lang="en-US" sz="1050" dirty="0">
                 <a:solidFill>
-                  <a:srgbClr val="6E7266"/>
+                  <a:srgbClr val="5B6B7A"/>
                 </a:solidFill>
               </a:rPr>
               <a:t>IN RFB 2.275/2025 (cronograma cartorial até 30/09/2026) · LC 214/2025 arts. 59, 265, 266 · FAQ RFB (repasses de IBS e CIB).</a:t>
@@ -7697,7 +7697,7 @@
             <a:r>
               <a:rPr lang="en-US" sz="1100" dirty="0">
                 <a:solidFill>
-                  <a:srgbClr val="6E7266"/>
+                  <a:srgbClr val="5B6B7A"/>
                 </a:solidFill>
               </a:rPr>
               <a:t>09</a:t>

</xml_diff>